<commit_message>
Cleaned up MMTO examples.
</commit_message>
<xml_diff>
--- a/Slides/MMTOResults.pptx
+++ b/Slides/MMTOResults.pptx
@@ -5,7 +5,7 @@
     <p:sldMasterId id="2147483648" r:id="rId1"/>
   </p:sldMasterIdLst>
   <p:notesMasterIdLst>
-    <p:notesMasterId r:id="rId10"/>
+    <p:notesMasterId r:id="rId11"/>
   </p:notesMasterIdLst>
   <p:sldIdLst>
     <p:sldId id="2381" r:id="rId2"/>
@@ -16,6 +16,7 @@
     <p:sldId id="2389" r:id="rId7"/>
     <p:sldId id="2390" r:id="rId8"/>
     <p:sldId id="2391" r:id="rId9"/>
+    <p:sldId id="2392" r:id="rId10"/>
   </p:sldIdLst>
   <p:sldSz cx="12192000" cy="6858000"/>
   <p:notesSz cx="6858000" cy="9144000"/>
@@ -204,7 +205,7 @@
           <a:p>
             <a:fld id="{317BC63F-E652-456B-B880-2F318D1A1929}" type="datetimeFigureOut">
               <a:rPr lang="en-US" smtClean="0"/>
-              <a:t>10/21/2025</a:t>
+              <a:t>10/22/2025</a:t>
             </a:fld>
             <a:endParaRPr lang="en-US"/>
           </a:p>
@@ -618,7 +619,7 @@
           <a:p>
             <a:fld id="{935B4303-DE67-4DA8-B375-7E6264E8BDE4}" type="datetimeFigureOut">
               <a:rPr lang="en-US" smtClean="0"/>
-              <a:t>10/21/2025</a:t>
+              <a:t>10/22/2025</a:t>
             </a:fld>
             <a:endParaRPr lang="en-US"/>
           </a:p>
@@ -816,7 +817,7 @@
           <a:p>
             <a:fld id="{935B4303-DE67-4DA8-B375-7E6264E8BDE4}" type="datetimeFigureOut">
               <a:rPr lang="en-US" smtClean="0"/>
-              <a:t>10/21/2025</a:t>
+              <a:t>10/22/2025</a:t>
             </a:fld>
             <a:endParaRPr lang="en-US"/>
           </a:p>
@@ -1024,7 +1025,7 @@
           <a:p>
             <a:fld id="{935B4303-DE67-4DA8-B375-7E6264E8BDE4}" type="datetimeFigureOut">
               <a:rPr lang="en-US" smtClean="0"/>
-              <a:t>10/21/2025</a:t>
+              <a:t>10/22/2025</a:t>
             </a:fld>
             <a:endParaRPr lang="en-US"/>
           </a:p>
@@ -1534,7 +1535,7 @@
           <a:p>
             <a:fld id="{935B4303-DE67-4DA8-B375-7E6264E8BDE4}" type="datetimeFigureOut">
               <a:rPr lang="en-US" smtClean="0"/>
-              <a:t>10/21/2025</a:t>
+              <a:t>10/22/2025</a:t>
             </a:fld>
             <a:endParaRPr lang="en-US"/>
           </a:p>
@@ -1809,7 +1810,7 @@
           <a:p>
             <a:fld id="{935B4303-DE67-4DA8-B375-7E6264E8BDE4}" type="datetimeFigureOut">
               <a:rPr lang="en-US" smtClean="0"/>
-              <a:t>10/21/2025</a:t>
+              <a:t>10/22/2025</a:t>
             </a:fld>
             <a:endParaRPr lang="en-US"/>
           </a:p>
@@ -2074,7 +2075,7 @@
           <a:p>
             <a:fld id="{935B4303-DE67-4DA8-B375-7E6264E8BDE4}" type="datetimeFigureOut">
               <a:rPr lang="en-US" smtClean="0"/>
-              <a:t>10/21/2025</a:t>
+              <a:t>10/22/2025</a:t>
             </a:fld>
             <a:endParaRPr lang="en-US"/>
           </a:p>
@@ -2486,7 +2487,7 @@
           <a:p>
             <a:fld id="{935B4303-DE67-4DA8-B375-7E6264E8BDE4}" type="datetimeFigureOut">
               <a:rPr lang="en-US" smtClean="0"/>
-              <a:t>10/21/2025</a:t>
+              <a:t>10/22/2025</a:t>
             </a:fld>
             <a:endParaRPr lang="en-US"/>
           </a:p>
@@ -2627,7 +2628,7 @@
           <a:p>
             <a:fld id="{935B4303-DE67-4DA8-B375-7E6264E8BDE4}" type="datetimeFigureOut">
               <a:rPr lang="en-US" smtClean="0"/>
-              <a:t>10/21/2025</a:t>
+              <a:t>10/22/2025</a:t>
             </a:fld>
             <a:endParaRPr lang="en-US"/>
           </a:p>
@@ -2740,7 +2741,7 @@
           <a:p>
             <a:fld id="{935B4303-DE67-4DA8-B375-7E6264E8BDE4}" type="datetimeFigureOut">
               <a:rPr lang="en-US" smtClean="0"/>
-              <a:t>10/21/2025</a:t>
+              <a:t>10/22/2025</a:t>
             </a:fld>
             <a:endParaRPr lang="en-US"/>
           </a:p>
@@ -3051,7 +3052,7 @@
           <a:p>
             <a:fld id="{935B4303-DE67-4DA8-B375-7E6264E8BDE4}" type="datetimeFigureOut">
               <a:rPr lang="en-US" smtClean="0"/>
-              <a:t>10/21/2025</a:t>
+              <a:t>10/22/2025</a:t>
             </a:fld>
             <a:endParaRPr lang="en-US"/>
           </a:p>
@@ -3339,7 +3340,7 @@
           <a:p>
             <a:fld id="{935B4303-DE67-4DA8-B375-7E6264E8BDE4}" type="datetimeFigureOut">
               <a:rPr lang="en-US" smtClean="0"/>
-              <a:t>10/21/2025</a:t>
+              <a:t>10/22/2025</a:t>
             </a:fld>
             <a:endParaRPr lang="en-US"/>
           </a:p>
@@ -3580,7 +3581,7 @@
           <a:p>
             <a:fld id="{935B4303-DE67-4DA8-B375-7E6264E8BDE4}" type="datetimeFigureOut">
               <a:rPr lang="en-US" smtClean="0"/>
-              <a:t>10/21/2025</a:t>
+              <a:t>10/22/2025</a:t>
             </a:fld>
             <a:endParaRPr lang="en-US"/>
           </a:p>
@@ -4184,7 +4185,7 @@
         </p:blipFill>
         <p:spPr>
           <a:xfrm>
-            <a:off x="381000" y="1725885"/>
+            <a:off x="647218" y="1579280"/>
             <a:ext cx="3685714" cy="2200000"/>
           </a:xfrm>
           <a:prstGeom prst="rect">
@@ -4214,7 +4215,7 @@
         </p:blipFill>
         <p:spPr>
           <a:xfrm>
-            <a:off x="284990" y="4587464"/>
+            <a:off x="409122" y="4056233"/>
             <a:ext cx="4161905" cy="990476"/>
           </a:xfrm>
           <a:prstGeom prst="rect">
@@ -4244,7 +4245,7 @@
         </p:blipFill>
         <p:spPr>
           <a:xfrm>
-            <a:off x="5656894" y="1579280"/>
+            <a:off x="6032499" y="1127317"/>
             <a:ext cx="5780952" cy="4190476"/>
           </a:xfrm>
           <a:prstGeom prst="rect">
@@ -5242,6 +5243,96 @@
           </a:p>
         </p:txBody>
       </p:sp>
+      <p:pic>
+        <p:nvPicPr>
+          <p:cNvPr id="4" name="Picture 3">
+            <a:extLst>
+              <a:ext uri="{FF2B5EF4-FFF2-40B4-BE49-F238E27FC236}">
+                <a16:creationId xmlns:a16="http://schemas.microsoft.com/office/drawing/2014/main" id="{662F36F5-8DA5-AD25-4C0A-50562B827858}"/>
+              </a:ext>
+            </a:extLst>
+          </p:cNvPr>
+          <p:cNvPicPr>
+            <a:picLocks noChangeAspect="1"/>
+          </p:cNvPicPr>
+          <p:nvPr/>
+        </p:nvPicPr>
+        <p:blipFill>
+          <a:blip r:embed="rId2"/>
+          <a:stretch>
+            <a:fillRect/>
+          </a:stretch>
+        </p:blipFill>
+        <p:spPr>
+          <a:xfrm>
+            <a:off x="1198026" y="1934419"/>
+            <a:ext cx="4168966" cy="2741753"/>
+          </a:xfrm>
+          <a:prstGeom prst="rect">
+            <a:avLst/>
+          </a:prstGeom>
+        </p:spPr>
+      </p:pic>
+      <p:pic>
+        <p:nvPicPr>
+          <p:cNvPr id="7" name="Picture 6">
+            <a:extLst>
+              <a:ext uri="{FF2B5EF4-FFF2-40B4-BE49-F238E27FC236}">
+                <a16:creationId xmlns:a16="http://schemas.microsoft.com/office/drawing/2014/main" id="{70325408-D924-2902-FD3D-ABCAA2213D93}"/>
+              </a:ext>
+            </a:extLst>
+          </p:cNvPr>
+          <p:cNvPicPr>
+            <a:picLocks noChangeAspect="1"/>
+          </p:cNvPicPr>
+          <p:nvPr/>
+        </p:nvPicPr>
+        <p:blipFill>
+          <a:blip r:embed="rId3"/>
+          <a:stretch>
+            <a:fillRect/>
+          </a:stretch>
+        </p:blipFill>
+        <p:spPr>
+          <a:xfrm>
+            <a:off x="6301090" y="916055"/>
+            <a:ext cx="5593565" cy="4099915"/>
+          </a:xfrm>
+          <a:prstGeom prst="rect">
+            <a:avLst/>
+          </a:prstGeom>
+        </p:spPr>
+      </p:pic>
+      <p:pic>
+        <p:nvPicPr>
+          <p:cNvPr id="10" name="Picture 9">
+            <a:extLst>
+              <a:ext uri="{FF2B5EF4-FFF2-40B4-BE49-F238E27FC236}">
+                <a16:creationId xmlns:a16="http://schemas.microsoft.com/office/drawing/2014/main" id="{C5EED1B8-7B1E-16E6-B557-3E153A0E7E34}"/>
+              </a:ext>
+            </a:extLst>
+          </p:cNvPr>
+          <p:cNvPicPr>
+            <a:picLocks noChangeAspect="1"/>
+          </p:cNvPicPr>
+          <p:nvPr/>
+        </p:nvPicPr>
+        <p:blipFill>
+          <a:blip r:embed="rId4"/>
+          <a:stretch>
+            <a:fillRect/>
+          </a:stretch>
+        </p:blipFill>
+        <p:spPr>
+          <a:xfrm>
+            <a:off x="895212" y="5340616"/>
+            <a:ext cx="4313294" cy="899238"/>
+          </a:xfrm>
+          <a:prstGeom prst="rect">
+            <a:avLst/>
+          </a:prstGeom>
+        </p:spPr>
+      </p:pic>
     </p:spTree>
     <p:extLst>
       <p:ext uri="{BB962C8B-B14F-4D97-AF65-F5344CB8AC3E}">
@@ -5542,7 +5633,7 @@
         </p:nvSpPr>
         <p:spPr>
           <a:xfrm>
-            <a:off x="284534" y="1466748"/>
+            <a:off x="87764" y="1107933"/>
             <a:ext cx="6094378" cy="286360"/>
           </a:xfrm>
           <a:prstGeom prst="rect">
@@ -5604,10 +5695,10 @@
       </p:sp>
       <p:pic>
         <p:nvPicPr>
-          <p:cNvPr id="7" name="Picture 6">
-            <a:extLst>
-              <a:ext uri="{FF2B5EF4-FFF2-40B4-BE49-F238E27FC236}">
-                <a16:creationId xmlns:a16="http://schemas.microsoft.com/office/drawing/2014/main" id="{DCB8C05F-29A3-CC09-F828-3FAD6834188B}"/>
+          <p:cNvPr id="5" name="Picture 4">
+            <a:extLst>
+              <a:ext uri="{FF2B5EF4-FFF2-40B4-BE49-F238E27FC236}">
+                <a16:creationId xmlns:a16="http://schemas.microsoft.com/office/drawing/2014/main" id="{9DD676ED-6E14-68CA-546A-0944F6FC8161}"/>
               </a:ext>
             </a:extLst>
           </p:cNvPr>
@@ -5624,8 +5715,8 @@
         </p:blipFill>
         <p:spPr>
           <a:xfrm>
-            <a:off x="767281" y="1965523"/>
-            <a:ext cx="4330013" cy="2776036"/>
+            <a:off x="784930" y="1535373"/>
+            <a:ext cx="3955123" cy="2591025"/>
           </a:xfrm>
           <a:prstGeom prst="rect">
             <a:avLst/>
@@ -5634,10 +5725,10 @@
       </p:pic>
       <p:pic>
         <p:nvPicPr>
-          <p:cNvPr id="10" name="Picture 9">
-            <a:extLst>
-              <a:ext uri="{FF2B5EF4-FFF2-40B4-BE49-F238E27FC236}">
-                <a16:creationId xmlns:a16="http://schemas.microsoft.com/office/drawing/2014/main" id="{1A51C0F2-AA24-852D-3BC4-DDB0029768D4}"/>
+          <p:cNvPr id="8" name="Picture 7">
+            <a:extLst>
+              <a:ext uri="{FF2B5EF4-FFF2-40B4-BE49-F238E27FC236}">
+                <a16:creationId xmlns:a16="http://schemas.microsoft.com/office/drawing/2014/main" id="{781D96A8-2486-4A62-4667-CA433D52955A}"/>
               </a:ext>
             </a:extLst>
           </p:cNvPr>
@@ -5654,8 +5745,8 @@
         </p:blipFill>
         <p:spPr>
           <a:xfrm>
-            <a:off x="381000" y="5308731"/>
-            <a:ext cx="3819048" cy="1047619"/>
+            <a:off x="5930400" y="1394293"/>
+            <a:ext cx="5753599" cy="4183743"/>
           </a:xfrm>
           <a:prstGeom prst="rect">
             <a:avLst/>
@@ -5664,10 +5755,10 @@
       </p:pic>
       <p:pic>
         <p:nvPicPr>
-          <p:cNvPr id="12" name="Picture 11">
-            <a:extLst>
-              <a:ext uri="{FF2B5EF4-FFF2-40B4-BE49-F238E27FC236}">
-                <a16:creationId xmlns:a16="http://schemas.microsoft.com/office/drawing/2014/main" id="{7755B613-5359-9B64-5171-669CD7D96CDF}"/>
+          <p:cNvPr id="13" name="Picture 12">
+            <a:extLst>
+              <a:ext uri="{FF2B5EF4-FFF2-40B4-BE49-F238E27FC236}">
+                <a16:creationId xmlns:a16="http://schemas.microsoft.com/office/drawing/2014/main" id="{00AA5BB2-E0A4-97C1-C986-3DF2FF5B4AD1}"/>
               </a:ext>
             </a:extLst>
           </p:cNvPr>
@@ -5684,8 +5775,8 @@
         </p:blipFill>
         <p:spPr>
           <a:xfrm>
-            <a:off x="5864951" y="1670635"/>
-            <a:ext cx="5819048" cy="4161905"/>
+            <a:off x="381000" y="4657968"/>
+            <a:ext cx="3741744" cy="1036410"/>
           </a:xfrm>
           <a:prstGeom prst="rect">
             <a:avLst/>
@@ -5798,86 +5889,12 @@
           </a:p>
         </p:txBody>
       </p:sp>
-      <p:sp>
-        <p:nvSpPr>
-          <p:cNvPr id="5" name="TextBox 4">
-            <a:extLst>
-              <a:ext uri="{FF2B5EF4-FFF2-40B4-BE49-F238E27FC236}">
-                <a16:creationId xmlns:a16="http://schemas.microsoft.com/office/drawing/2014/main" id="{F06DF53C-50AD-AFFE-8417-72A2597DF826}"/>
-              </a:ext>
-            </a:extLst>
-          </p:cNvPr>
-          <p:cNvSpPr txBox="1"/>
-          <p:nvPr/>
-        </p:nvSpPr>
-        <p:spPr>
-          <a:xfrm>
-            <a:off x="0" y="1260248"/>
-            <a:ext cx="7838062" cy="286360"/>
-          </a:xfrm>
-          <a:prstGeom prst="rect">
-            <a:avLst/>
-          </a:prstGeom>
-          <a:noFill/>
-        </p:spPr>
-        <p:txBody>
-          <a:bodyPr wrap="square">
-            <a:spAutoFit/>
-          </a:bodyPr>
-          <a:lstStyle/>
-          <a:p>
-            <a:pPr>
-              <a:lnSpc>
-                <a:spcPts val="1425"/>
-              </a:lnSpc>
-              <a:buNone/>
-            </a:pPr>
-            <a:r>
-              <a:rPr lang="en-US" b="0" dirty="0" err="1">
-                <a:solidFill>
-                  <a:srgbClr val="4EC9B0"/>
-                </a:solidFill>
-                <a:effectLst/>
-                <a:latin typeface="Consolas" panose="020B0609020204030204" pitchFamily="49" charset="0"/>
-              </a:rPr>
-              <a:t>MMTOExamples</a:t>
-            </a:r>
-            <a:r>
-              <a:rPr lang="en-US" b="0" dirty="0" err="1">
-                <a:solidFill>
-                  <a:srgbClr val="CCCCCC"/>
-                </a:solidFill>
-                <a:effectLst/>
-                <a:latin typeface="Consolas" panose="020B0609020204030204" pitchFamily="49" charset="0"/>
-              </a:rPr>
-              <a:t>.</a:t>
-            </a:r>
-            <a:r>
-              <a:rPr lang="en-US" b="0" dirty="0" err="1">
-                <a:solidFill>
-                  <a:srgbClr val="4FC1FF"/>
-                </a:solidFill>
-                <a:effectLst/>
-                <a:latin typeface="Consolas" panose="020B0609020204030204" pitchFamily="49" charset="0"/>
-              </a:rPr>
-              <a:t>BliskSection_Mass_ComplianceCriticality</a:t>
-            </a:r>
-            <a:endParaRPr lang="en-US" b="0" dirty="0">
-              <a:solidFill>
-                <a:srgbClr val="CCCCCC"/>
-              </a:solidFill>
-              <a:effectLst/>
-              <a:latin typeface="Consolas" panose="020B0609020204030204" pitchFamily="49" charset="0"/>
-            </a:endParaRPr>
-          </a:p>
-        </p:txBody>
-      </p:sp>
       <p:pic>
         <p:nvPicPr>
-          <p:cNvPr id="15" name="Picture 14">
-            <a:extLst>
-              <a:ext uri="{FF2B5EF4-FFF2-40B4-BE49-F238E27FC236}">
-                <a16:creationId xmlns:a16="http://schemas.microsoft.com/office/drawing/2014/main" id="{7331ECF3-8C23-F14E-E5F8-B399FB83D7B4}"/>
+          <p:cNvPr id="4" name="Picture 3">
+            <a:extLst>
+              <a:ext uri="{FF2B5EF4-FFF2-40B4-BE49-F238E27FC236}">
+                <a16:creationId xmlns:a16="http://schemas.microsoft.com/office/drawing/2014/main" id="{D312A068-B35E-CC70-14FD-C2F3E2EE5D2B}"/>
               </a:ext>
             </a:extLst>
           </p:cNvPr>
@@ -5894,8 +5911,8 @@
         </p:blipFill>
         <p:spPr>
           <a:xfrm>
-            <a:off x="702906" y="1828799"/>
-            <a:ext cx="4222981" cy="2904587"/>
+            <a:off x="381000" y="1833695"/>
+            <a:ext cx="4138019" cy="2773920"/>
           </a:xfrm>
           <a:prstGeom prst="rect">
             <a:avLst/>
@@ -5904,10 +5921,10 @@
       </p:pic>
       <p:pic>
         <p:nvPicPr>
-          <p:cNvPr id="17" name="Picture 16">
-            <a:extLst>
-              <a:ext uri="{FF2B5EF4-FFF2-40B4-BE49-F238E27FC236}">
-                <a16:creationId xmlns:a16="http://schemas.microsoft.com/office/drawing/2014/main" id="{20806C39-8634-CFAD-BEA7-19B4E3C7EE63}"/>
+          <p:cNvPr id="7" name="Picture 6">
+            <a:extLst>
+              <a:ext uri="{FF2B5EF4-FFF2-40B4-BE49-F238E27FC236}">
+                <a16:creationId xmlns:a16="http://schemas.microsoft.com/office/drawing/2014/main" id="{C115B7ED-B570-AD1E-456D-22C29485C908}"/>
               </a:ext>
             </a:extLst>
           </p:cNvPr>
@@ -5924,8 +5941,8 @@
         </p:blipFill>
         <p:spPr>
           <a:xfrm>
-            <a:off x="577514" y="5171734"/>
-            <a:ext cx="3819048" cy="1047619"/>
+            <a:off x="525971" y="5068116"/>
+            <a:ext cx="4496190" cy="1059272"/>
           </a:xfrm>
           <a:prstGeom prst="rect">
             <a:avLst/>
@@ -5934,10 +5951,10 @@
       </p:pic>
       <p:pic>
         <p:nvPicPr>
-          <p:cNvPr id="19" name="Picture 18">
-            <a:extLst>
-              <a:ext uri="{FF2B5EF4-FFF2-40B4-BE49-F238E27FC236}">
-                <a16:creationId xmlns:a16="http://schemas.microsoft.com/office/drawing/2014/main" id="{1015963A-9538-5F06-FF03-165666246944}"/>
+          <p:cNvPr id="10" name="Picture 9">
+            <a:extLst>
+              <a:ext uri="{FF2B5EF4-FFF2-40B4-BE49-F238E27FC236}">
+                <a16:creationId xmlns:a16="http://schemas.microsoft.com/office/drawing/2014/main" id="{7436DF42-A97A-929F-8C65-387CE8D9D82F}"/>
               </a:ext>
             </a:extLst>
           </p:cNvPr>
@@ -5954,18 +5971,272 @@
         </p:blipFill>
         <p:spPr>
           <a:xfrm>
-            <a:off x="5753800" y="1828799"/>
-            <a:ext cx="5600000" cy="4266667"/>
+            <a:off x="5930400" y="1660788"/>
+            <a:ext cx="5753599" cy="4115157"/>
           </a:xfrm>
           <a:prstGeom prst="rect">
             <a:avLst/>
           </a:prstGeom>
         </p:spPr>
       </p:pic>
+      <p:sp>
+        <p:nvSpPr>
+          <p:cNvPr id="6" name="TextBox 5">
+            <a:extLst>
+              <a:ext uri="{FF2B5EF4-FFF2-40B4-BE49-F238E27FC236}">
+                <a16:creationId xmlns:a16="http://schemas.microsoft.com/office/drawing/2014/main" id="{A2D0B6FA-25B9-761F-32B1-9C0DF31E0509}"/>
+              </a:ext>
+            </a:extLst>
+          </p:cNvPr>
+          <p:cNvSpPr txBox="1"/>
+          <p:nvPr/>
+        </p:nvSpPr>
+        <p:spPr>
+          <a:xfrm>
+            <a:off x="380999" y="1075848"/>
+            <a:ext cx="7837025" cy="267124"/>
+          </a:xfrm>
+          <a:prstGeom prst="rect">
+            <a:avLst/>
+          </a:prstGeom>
+          <a:noFill/>
+        </p:spPr>
+        <p:txBody>
+          <a:bodyPr wrap="square">
+            <a:spAutoFit/>
+          </a:bodyPr>
+          <a:lstStyle/>
+          <a:p>
+            <a:pPr>
+              <a:lnSpc>
+                <a:spcPts val="1200"/>
+              </a:lnSpc>
+              <a:buNone/>
+            </a:pPr>
+            <a:r>
+              <a:rPr lang="en-US" b="0" dirty="0" err="1">
+                <a:solidFill>
+                  <a:srgbClr val="4EC9B0"/>
+                </a:solidFill>
+                <a:effectLst/>
+                <a:latin typeface="Consolas" panose="020B0609020204030204" pitchFamily="49" charset="0"/>
+              </a:rPr>
+              <a:t>MMTOExamples</a:t>
+            </a:r>
+            <a:r>
+              <a:rPr lang="en-US" b="0" dirty="0" err="1">
+                <a:solidFill>
+                  <a:srgbClr val="CCCCCC"/>
+                </a:solidFill>
+                <a:effectLst/>
+                <a:latin typeface="Consolas" panose="020B0609020204030204" pitchFamily="49" charset="0"/>
+              </a:rPr>
+              <a:t>.</a:t>
+            </a:r>
+            <a:r>
+              <a:rPr lang="en-US" b="0" dirty="0" err="1">
+                <a:solidFill>
+                  <a:srgbClr val="4FC1FF"/>
+                </a:solidFill>
+                <a:effectLst/>
+                <a:latin typeface="Consolas" panose="020B0609020204030204" pitchFamily="49" charset="0"/>
+              </a:rPr>
+              <a:t>BliskSection_Compliance_MassCriticality</a:t>
+            </a:r>
+            <a:endParaRPr lang="en-US" b="0" dirty="0">
+              <a:solidFill>
+                <a:srgbClr val="CCCCCC"/>
+              </a:solidFill>
+              <a:effectLst/>
+              <a:latin typeface="Consolas" panose="020B0609020204030204" pitchFamily="49" charset="0"/>
+            </a:endParaRPr>
+          </a:p>
+        </p:txBody>
+      </p:sp>
     </p:spTree>
     <p:extLst>
       <p:ext uri="{BB962C8B-B14F-4D97-AF65-F5344CB8AC3E}">
         <p14:creationId xmlns:p14="http://schemas.microsoft.com/office/powerpoint/2010/main" val="2687041123"/>
+      </p:ext>
+    </p:extLst>
+  </p:cSld>
+  <p:clrMapOvr>
+    <a:masterClrMapping/>
+  </p:clrMapOvr>
+</p:sld>
+</file>
+
+<file path=ppt/slides/slide9.xml><?xml version="1.0" encoding="utf-8"?>
+<p:sld xmlns:a="http://schemas.openxmlformats.org/drawingml/2006/main" xmlns:r="http://schemas.openxmlformats.org/officeDocument/2006/relationships" xmlns:p="http://schemas.openxmlformats.org/presentationml/2006/main">
+  <p:cSld>
+    <p:spTree>
+      <p:nvGrpSpPr>
+        <p:cNvPr id="1" name="">
+          <a:extLst>
+            <a:ext uri="{FF2B5EF4-FFF2-40B4-BE49-F238E27FC236}">
+              <a16:creationId xmlns:a16="http://schemas.microsoft.com/office/drawing/2014/main" id="{7E6F1A8C-814F-7C47-61A6-3EA5E2054511}"/>
+            </a:ext>
+          </a:extLst>
+        </p:cNvPr>
+        <p:cNvGrpSpPr/>
+        <p:nvPr/>
+      </p:nvGrpSpPr>
+      <p:grpSpPr>
+        <a:xfrm>
+          <a:off x="0" y="0"/>
+          <a:ext cx="0" cy="0"/>
+          <a:chOff x="0" y="0"/>
+          <a:chExt cx="0" cy="0"/>
+        </a:xfrm>
+      </p:grpSpPr>
+      <p:sp>
+        <p:nvSpPr>
+          <p:cNvPr id="3" name="Slide Number Placeholder 2">
+            <a:extLst>
+              <a:ext uri="{FF2B5EF4-FFF2-40B4-BE49-F238E27FC236}">
+                <a16:creationId xmlns:a16="http://schemas.microsoft.com/office/drawing/2014/main" id="{45F96852-22AA-5E5B-2629-375771764254}"/>
+              </a:ext>
+            </a:extLst>
+          </p:cNvPr>
+          <p:cNvSpPr>
+            <a:spLocks noGrp="1"/>
+          </p:cNvSpPr>
+          <p:nvPr>
+            <p:ph type="sldNum" sz="quarter" idx="11"/>
+          </p:nvPr>
+        </p:nvSpPr>
+        <p:spPr/>
+        <p:txBody>
+          <a:bodyPr/>
+          <a:lstStyle/>
+          <a:p>
+            <a:pPr>
+              <a:defRPr/>
+            </a:pPr>
+            <a:fld id="{231CC523-8BC6-4921-807A-66BD262F34AB}" type="slidenum">
+              <a:rPr lang="en-US" smtClean="0"/>
+              <a:pPr>
+                <a:defRPr/>
+              </a:pPr>
+              <a:t>9</a:t>
+            </a:fld>
+            <a:endParaRPr lang="en-US"/>
+          </a:p>
+        </p:txBody>
+      </p:sp>
+      <p:sp>
+        <p:nvSpPr>
+          <p:cNvPr id="9" name="Title 8">
+            <a:extLst>
+              <a:ext uri="{FF2B5EF4-FFF2-40B4-BE49-F238E27FC236}">
+                <a16:creationId xmlns:a16="http://schemas.microsoft.com/office/drawing/2014/main" id="{201E4D27-C554-A0B0-BD84-A666D5EDB116}"/>
+              </a:ext>
+            </a:extLst>
+          </p:cNvPr>
+          <p:cNvSpPr>
+            <a:spLocks noGrp="1"/>
+          </p:cNvSpPr>
+          <p:nvPr>
+            <p:ph type="ctrTitle"/>
+          </p:nvPr>
+        </p:nvSpPr>
+        <p:spPr>
+          <a:xfrm>
+            <a:off x="381000" y="126366"/>
+            <a:ext cx="11302999" cy="612648"/>
+          </a:xfrm>
+        </p:spPr>
+        <p:txBody>
+          <a:bodyPr>
+            <a:normAutofit/>
+          </a:bodyPr>
+          <a:lstStyle/>
+          <a:p>
+            <a:r>
+              <a:rPr lang="en-US" dirty="0"/>
+              <a:t>Example 10</a:t>
+            </a:r>
+          </a:p>
+        </p:txBody>
+      </p:sp>
+      <p:sp>
+        <p:nvSpPr>
+          <p:cNvPr id="11" name="TextBox 10">
+            <a:extLst>
+              <a:ext uri="{FF2B5EF4-FFF2-40B4-BE49-F238E27FC236}">
+                <a16:creationId xmlns:a16="http://schemas.microsoft.com/office/drawing/2014/main" id="{823E5D6D-1EA0-15B1-F54B-BE0CBCB90C82}"/>
+              </a:ext>
+            </a:extLst>
+          </p:cNvPr>
+          <p:cNvSpPr txBox="1"/>
+          <p:nvPr/>
+        </p:nvSpPr>
+        <p:spPr>
+          <a:xfrm>
+            <a:off x="222812" y="1311564"/>
+            <a:ext cx="6953491" cy="267124"/>
+          </a:xfrm>
+          <a:prstGeom prst="rect">
+            <a:avLst/>
+          </a:prstGeom>
+          <a:noFill/>
+        </p:spPr>
+        <p:txBody>
+          <a:bodyPr wrap="square">
+            <a:spAutoFit/>
+          </a:bodyPr>
+          <a:lstStyle/>
+          <a:p>
+            <a:pPr>
+              <a:lnSpc>
+                <a:spcPts val="1200"/>
+              </a:lnSpc>
+              <a:buNone/>
+            </a:pPr>
+            <a:r>
+              <a:rPr lang="en-US" b="0" dirty="0" err="1">
+                <a:solidFill>
+                  <a:srgbClr val="4EC9B0"/>
+                </a:solidFill>
+                <a:effectLst/>
+                <a:latin typeface="Consolas" panose="020B0609020204030204" pitchFamily="49" charset="0"/>
+              </a:rPr>
+              <a:t>MMTOExamples</a:t>
+            </a:r>
+            <a:r>
+              <a:rPr lang="en-US" b="0" dirty="0" err="1">
+                <a:solidFill>
+                  <a:srgbClr val="CCCCCC"/>
+                </a:solidFill>
+                <a:effectLst/>
+                <a:latin typeface="Consolas" panose="020B0609020204030204" pitchFamily="49" charset="0"/>
+              </a:rPr>
+              <a:t>.</a:t>
+            </a:r>
+            <a:r>
+              <a:rPr lang="en-US" b="0" dirty="0" err="1">
+                <a:solidFill>
+                  <a:srgbClr val="4FC1FF"/>
+                </a:solidFill>
+                <a:effectLst/>
+                <a:latin typeface="Consolas" panose="020B0609020204030204" pitchFamily="49" charset="0"/>
+              </a:rPr>
+              <a:t>BliskSection_Mass_StressSFCriticality</a:t>
+            </a:r>
+            <a:endParaRPr lang="en-US" b="0" dirty="0">
+              <a:solidFill>
+                <a:srgbClr val="CCCCCC"/>
+              </a:solidFill>
+              <a:effectLst/>
+              <a:latin typeface="Consolas" panose="020B0609020204030204" pitchFamily="49" charset="0"/>
+            </a:endParaRPr>
+          </a:p>
+        </p:txBody>
+      </p:sp>
+    </p:spTree>
+    <p:extLst>
+      <p:ext uri="{BB962C8B-B14F-4D97-AF65-F5344CB8AC3E}">
+        <p14:creationId xmlns:p14="http://schemas.microsoft.com/office/powerpoint/2010/main" val="1956195768"/>
       </p:ext>
     </p:extLst>
   </p:cSld>

</xml_diff>

<commit_message>
Version sent to DARPA
</commit_message>
<xml_diff>
--- a/Slides/MMTOResults.pptx
+++ b/Slides/MMTOResults.pptx
@@ -4195,7 +4195,7 @@
             </a:r>
             <a:r>
               <a:rPr lang="en-US" b="1" dirty="0"/>
-              <a:t>constant-temperature</a:t>
+              <a:t>pure structural</a:t>
             </a:r>
             <a:r>
               <a:rPr lang="en-US" dirty="0"/>
@@ -4515,7 +4515,7 @@
                   <a:srgbClr val="FFFF00"/>
                 </a:highlight>
               </a:rPr>
-              <a:t>Max criticality constraint ensures that materials of criticality are avoided</a:t>
+              <a:t>Max criticality constraint ensures that materials of high criticality are avoided.</a:t>
             </a:r>
           </a:p>
         </p:txBody>
@@ -5410,8 +5410,8 @@
         </p:nvSpPr>
         <p:spPr>
           <a:xfrm>
-            <a:off x="1563304" y="6269969"/>
-            <a:ext cx="7417494" cy="461665"/>
+            <a:off x="3982751" y="5984820"/>
+            <a:ext cx="4627849" cy="461665"/>
           </a:xfrm>
           <a:prstGeom prst="rect">
             <a:avLst/>
@@ -6063,7 +6063,7 @@
                   <a:srgbClr val="FFFF00"/>
                 </a:highlight>
               </a:rPr>
-              <a:t>We can enforce mean criticality (as opposed to max criticality)</a:t>
+              <a:t>We can also enforce mean criticality (as opposed to max criticality).</a:t>
             </a:r>
           </a:p>
         </p:txBody>
@@ -6169,7 +6169,7 @@
           <a:p>
             <a:r>
               <a:rPr lang="en-US" dirty="0"/>
-              <a:t>Example 10</a:t>
+              <a:t>Example 8</a:t>
             </a:r>
           </a:p>
         </p:txBody>
@@ -7192,7 +7192,7 @@
         <p:spPr>
           <a:xfrm>
             <a:off x="838200" y="5707915"/>
-            <a:ext cx="3965583" cy="830997"/>
+            <a:ext cx="3965583" cy="1200329"/>
           </a:xfrm>
           <a:prstGeom prst="rect">
             <a:avLst/>
@@ -7211,7 +7211,7 @@
                   <a:srgbClr val="FFFF00"/>
                 </a:highlight>
               </a:rPr>
-              <a:t>All attributes reconstruction errors are within 0.001% </a:t>
+              <a:t>Training takes about 3 mins. All attributes reconstruction errors are within 0.001% </a:t>
             </a:r>
           </a:p>
         </p:txBody>
@@ -7844,7 +7844,7 @@
         <p:spPr>
           <a:xfrm>
             <a:off x="5091886" y="5065385"/>
-            <a:ext cx="6922635" cy="830997"/>
+            <a:ext cx="4927603" cy="830997"/>
           </a:xfrm>
           <a:prstGeom prst="rect">
             <a:avLst/>
@@ -7863,7 +7863,7 @@
                   <a:srgbClr val="FFFF00"/>
                 </a:highlight>
               </a:rPr>
-              <a:t>Our 3D solution is within 2% of the 2D benchmark solution. We can easily handle 20+ materials.</a:t>
+              <a:t>Our 3D solution is within 2% of the 2D benchmark solution. </a:t>
             </a:r>
           </a:p>
         </p:txBody>
@@ -8079,7 +8079,7 @@
         <p:spPr>
           <a:xfrm>
             <a:off x="6160975" y="3608844"/>
-            <a:ext cx="5650025" cy="2226404"/>
+            <a:ext cx="5385757" cy="2122269"/>
           </a:xfrm>
           <a:prstGeom prst="rect">
             <a:avLst/>
@@ -8100,7 +8100,7 @@
         </p:nvSpPr>
         <p:spPr>
           <a:xfrm>
-            <a:off x="7439628" y="5893777"/>
+            <a:off x="7323447" y="5779837"/>
             <a:ext cx="4036268" cy="827698"/>
           </a:xfrm>
           <a:prstGeom prst="rect">

</xml_diff>